<commit_message>
Update proposal deck to the revised design
Slides and speaker notes now describe the acceleration factor (48
configurations), the RTX 5080 / T4 / GH200 precision support, H1 as a
control, the kernel smoke test and the new cut order.

Co-Authored-By: Claude Opus 5.5 <noreply@anthropic.com>
</commit_message>
<xml_diff>
--- a/docs/Hardware_Efficient_GenModels_Proposal.pptx
+++ b/docs/Hardware_Efficient_GenModels_Proposal.pptx
@@ -511,7 +511,7 @@
           <a:p>
             <a:r>
               <a:rPr lang="en-US" dirty="0"/>
-              <a:t>One-line pitch: papers report 'this sampler needs fewer steps', but steps are not seconds or joules. I test whether diffusion-vs-flow efficiency conclusions survive a change of GPU. The figure is a cartoon of why flow matching might need fewer steps: straighter paths.</a:t>
+              <a:t>One-line pitch: papers report '2× faster', but that number is measured on one GPU, and caching or 8-bit kernels change the cost of a call without changing the step count. I test whether those conclusions, and diffusion-vs-flow ones, survive a change of GPU. The figure is a cartoon of why flow matching might need fewer steps: straighter paths.</a:t>
             </a:r>
             <a:endParaRPr lang="en-US" dirty="0"/>
           </a:p>
@@ -687,7 +687,7 @@
           <a:p>
             <a:r>
               <a:rPr lang="en-US" dirty="0"/>
-              <a:t>Three sub-questions map to three hypotheses. They are falsifiable: if rankings are stable, that is also a useful result — it validates NFE as a proxy in this range.</a:t>
+              <a:t>H1 is a control: DiT and SiT have the same architecture and GFLOPs, so without acceleration NFE should predict latency on every GPU. H2 and H3 are the real tests. All three are falsifiable; stable rankings would also be a useful result.</a:t>
             </a:r>
             <a:endParaRPr lang="en-US" dirty="0"/>
           </a:p>
@@ -775,7 +775,7 @@
           <a:p>
             <a:r>
               <a:rPr lang="en-US" dirty="0"/>
-              <a:t>Link to class material: diffusion/score models, flow matching, ODE solvers, and generative-model evaluation (FID, precision/recall). The contribution is methodological: measured cost instead of proxy cost.</a:t>
+              <a:t>Link to class material: diffusion/score models, flow matching, ODE solvers, and generative-model evaluation (FID, precision/recall). The FORA number is from AccelAes (ECCV 2026): 0.99× on an RTX 5090 at batch 1. The contribution is methodological: measured cost instead of proxy cost.</a:t>
             </a:r>
             <a:endParaRPr lang="en-US" dirty="0"/>
           </a:p>
@@ -863,7 +863,7 @@
           <a:p>
             <a:r>
               <a:rPr lang="en-US" dirty="0"/>
-              <a:t>24 = 2 models × 2 samplers each × 3 step counts × 2 precisions. Batch size varies only for timing. Every network evaluation counts toward NFE — both CFG passes and Heun's second evaluation per step.</a:t>
+              <a:t>48 = 2 models × 2 samplers each × 3 step counts × 4 accelerations (none, feature caching, INT8, FP8). Batch size varies only for timing. Every network evaluation counts toward NFE, both CFG passes and Heun's second evaluation per step; FLOPs are counted separately so cached calls show as cheaper calls.</a:t>
             </a:r>
             <a:endParaRPr lang="en-US" dirty="0"/>
           </a:p>
@@ -951,7 +951,7 @@
           <a:p>
             <a:r>
               <a:rPr lang="en-US" dirty="0"/>
-              <a:t>The devices span roughly three GPU generations with very different memory bandwidth and precision support. One GPU per run keeps GH200 numbers comparable. Medians and IQRs, not means, because GPU timings have long tails.</a:t>
+              <a:t>Three GPU generations with different precision support: the T4 has no bf16 or FP8, the 5080 and GH200 have FP8. Anything a GPU cannot run is marked unavailable after the week-1 smoke test, and that gap is part of the result. The software stack cannot be identical (Colab fixes its own, the GH200 host is ARM), so: one implementation per method, pinned versions, logged per run. Medians and IQRs because GPU timings have long tails.</a:t>
             </a:r>
             <a:endParaRPr lang="en-US" dirty="0"/>
           </a:p>
@@ -1039,7 +1039,7 @@
           <a:p>
             <a:r>
               <a:rPr lang="en-US" dirty="0"/>
-              <a:t>Quality is a property of model + sampler + precision, not of the GPU, up to numerical noise. I verify that assumption on selected outputs per device rather than assuming it.</a:t>
+              <a:t>Quality is a property of the configuration, not the GPU, up to numerical noise. The 5080 is the only device that runs every configuration, so all images are generated there; a subset is re-generated on the other two to check the assumption. FID is compared only at equal sample counts because it is biased at small N.</a:t>
             </a:r>
             <a:endParaRPr lang="en-US" dirty="0"/>
           </a:p>
@@ -1127,7 +1127,7 @@
           <a:p>
             <a:r>
               <a:rPr lang="en-US" dirty="0"/>
-              <a:t>Walk through the schematic: on GPU A the red configs form a frontier; on GPU B one of them becomes dominated. That is the H2 failure mode I'm testing for. For H3, matching on steps or NFE would be unfair to Heun and multistep solvers; milliseconds and joules are what a practitioner pays.</a:t>
+              <a:t>Walk through the schematic: on GPU A the red configs form a frontier; on GPU B one of them becomes dominated. That is the H2 failure mode, and accelerated configs are the likely candidates. For H3 the mechanism check is cheap: log the cosine similarity of consecutive-step block outputs during sampling.</a:t>
             </a:r>
             <a:endParaRPr lang="en-US" dirty="0"/>
           </a:p>
@@ -1215,7 +1215,7 @@
           <a:p>
             <a:r>
               <a:rPr lang="en-US" dirty="0"/>
-              <a:t>The degradation path is ordered: the core comparison survives every cut. What gets cut is breadth, never the research question. Out of scope: serving systems, training from scratch, exhaustive solver search.</a:t>
+              <a:t>The degradation path is ordered: the core comparison survives every cut. What gets cut is breadth, never the research question. Caching failing at 8 steps is a prediction, not a risk. Out of scope: serving systems, training, exhaustive solver search.</a:t>
             </a:r>
             <a:endParaRPr lang="en-US" dirty="0"/>
           </a:p>
@@ -1303,7 +1303,7 @@
           <a:p>
             <a:r>
               <a:rPr lang="en-US" dirty="0"/>
-              <a:t>Three checkpoints: harness validated by week 4, pilot frontier by week 7, cross-device data by week 9. If week 9 slips, the fallbacks from the previous slide kick in.</a:t>
+              <a:t>Three checkpoints: harness validated by week 4, pilot frontier by week 7, cross-device data by week 9. Weeks 1–2 include the kernel smoke test, so what runs where is fixed before any sweep. If week 9 slips, the fallbacks from the previous slide kick in.</a:t>
             </a:r>
             <a:endParaRPr lang="en-US" dirty="0"/>
           </a:p>
@@ -1787,7 +1787,7 @@
                 <a:ea typeface="Georgia" pitchFamily="34" charset="-122"/>
                 <a:cs typeface="Georgia" pitchFamily="34" charset="-120"/>
               </a:rPr>
-              <a:t>Diffusion and flow-matching samplers, measured across heterogeneous GPUs.</a:t>
+              <a:t>Diffusion and flow-matching samplers with caching and INT8/FP8, measured across three GPU generations.</a:t>
             </a:r>
             <a:endParaRPr lang="en-US" sz="1400" dirty="0"/>
           </a:p>
@@ -3644,7 +3644,7 @@
                 <a:ea typeface="Georgia" pitchFamily="34" charset="-122"/>
                 <a:cs typeface="Georgia" pitchFamily="34" charset="-120"/>
               </a:rPr>
-              <a:t>Evidence-based guidance on when NFE is a trustworthy proxy</a:t>
+              <a:t>Evidence on when NFE or FLOPs can stand in for measured cost</a:t>
             </a:r>
             <a:endParaRPr lang="en-US" sz="1800" dirty="0"/>
           </a:p>
@@ -3706,7 +3706,7 @@
                 <a:ea typeface="Arial" pitchFamily="34" charset="-122"/>
                 <a:cs typeface="Arial" pitchFamily="34" charset="-120"/>
               </a:rPr>
-              <a:t>Either outcome is informative: stable rankings validate NFE; unstable ones mean efficiency claims need their hardware attached.</a:t>
+              <a:t>Either outcome is informative: stable rankings validate NFE and FLOPs; unstable ones mean speedup claims need their hardware attached.</a:t>
             </a:r>
             <a:endParaRPr lang="en-US" sz="1250" dirty="0"/>
           </a:p>
@@ -3855,7 +3855,7 @@
                 <a:ea typeface="Georgia" pitchFamily="34" charset="-122"/>
                 <a:cs typeface="Georgia" pitchFamily="34" charset="-120"/>
               </a:rPr>
-              <a:t>Is NFE a trustworthy proxy for efficiency?</a:t>
+              <a:t>Does NFE still predict cost once calls get cheaper?</a:t>
             </a:r>
             <a:endParaRPr lang="en-US" sz="2500" dirty="0"/>
           </a:p>
@@ -4018,7 +4018,7 @@
                 <a:ea typeface="Georgia" pitchFamily="34" charset="-122"/>
                 <a:cs typeface="Georgia" pitchFamily="34" charset="-120"/>
               </a:rPr>
-              <a:t>“Do diffusion and flow-matching sampler rankings remain stable across GPU classes and numerical precisions?”</a:t>
+              <a:t>“When an acceleration changes the cost of a network call but not the number of calls, do quality–cost rankings survive a change of GPU?”</a:t>
             </a:r>
             <a:endParaRPr lang="en-US" sz="1700" dirty="0"/>
           </a:p>
@@ -4096,7 +4096,7 @@
                 <a:ea typeface="Georgia" pitchFamily="34" charset="-122"/>
                 <a:cs typeface="Georgia" pitchFamily="34" charset="-120"/>
               </a:rPr>
-              <a:t>NFE ≠ cost</a:t>
+              <a:t>Control</a:t>
             </a:r>
             <a:endParaRPr lang="en-US" sz="1400" dirty="0"/>
           </a:p>
@@ -4135,7 +4135,7 @@
                 <a:ea typeface="Arial" pitchFamily="34" charset="-122"/>
                 <a:cs typeface="Arial" pitchFamily="34" charset="-120"/>
               </a:rPr>
-              <a:t>NFE tracks latency within one GPU and sampler, but misses solver overhead, memory bandwidth and precision support.</a:t>
+              <a:t>Without acceleration, latency is linear in NFE on every device. DiT and SiT cost the same per call, so this validates the harness.</a:t>
             </a:r>
             <a:endParaRPr lang="en-US" sz="1100" dirty="0"/>
           </a:p>
@@ -4275,7 +4275,7 @@
                 <a:ea typeface="Arial" pitchFamily="34" charset="-122"/>
                 <a:cs typeface="Arial" pitchFamily="34" charset="-120"/>
               </a:rPr>
-              <a:t>Near-frontier configurations can swap rank between devices — a single-GPU Pareto front can mislead.</a:t>
+              <a:t>Caching and INT8/FP8 speedups depend on GPU and batch size, so they reorder the frontier in ways NFE and FLOPs cannot predict.</a:t>
             </a:r>
             <a:endParaRPr lang="en-US" sz="1100" dirty="0"/>
           </a:p>
@@ -4376,7 +4376,7 @@
                 <a:ea typeface="Georgia" pitchFamily="34" charset="-122"/>
                 <a:cs typeface="Georgia" pitchFamily="34" charset="-120"/>
               </a:rPr>
-              <a:t>Straight paths pay off</a:t>
+              <a:t>Who tolerates caching</a:t>
             </a:r>
             <a:endParaRPr lang="en-US" sz="1400" dirty="0"/>
           </a:p>
@@ -4415,7 +4415,7 @@
                 <a:ea typeface="Arial" pitchFamily="34" charset="-122"/>
                 <a:cs typeface="Arial" pitchFamily="34" charset="-120"/>
               </a:rPr>
-              <a:t>Flow matching loses quality more slowly in the low-step regime, compared at matched measured cost.</a:t>
+              <a:t>Flow matching should lose less quality under caching than diffusion. At 8 steps caching is predicted to fail outright.</a:t>
             </a:r>
             <a:endParaRPr lang="en-US" sz="1100" dirty="0"/>
           </a:p>
@@ -4750,7 +4750,7 @@
                 <a:ea typeface="Georgia" pitchFamily="34" charset="-122"/>
                 <a:cs typeface="Georgia" pitchFamily="34" charset="-120"/>
               </a:rPr>
-              <a:t>Diffusion</a:t>
+              <a:t>Two families</a:t>
             </a:r>
             <a:endParaRPr lang="en-US" sz="1250" dirty="0"/>
           </a:p>
@@ -4789,7 +4789,7 @@
                 <a:ea typeface="Arial" pitchFamily="34" charset="-122"/>
                 <a:cs typeface="Arial" pitchFamily="34" charset="-120"/>
               </a:rPr>
-              <a:t>iterative denoising; DDIM and DPM-Solver cut sampling to tens of steps</a:t>
+              <a:t>diffusion denoises iteratively; flow matching follows straighter paths</a:t>
             </a:r>
             <a:endParaRPr lang="en-US" sz="1050" dirty="0"/>
           </a:p>
@@ -4851,7 +4851,7 @@
                 <a:ea typeface="Georgia" pitchFamily="34" charset="-122"/>
                 <a:cs typeface="Georgia" pitchFamily="34" charset="-120"/>
               </a:rPr>
-              <a:t>Flow matching</a:t>
+              <a:t>Cheaper calls</a:t>
             </a:r>
             <a:endParaRPr lang="en-US" sz="1250" dirty="0"/>
           </a:p>
@@ -4890,7 +4890,7 @@
                 <a:ea typeface="Arial" pitchFamily="34" charset="-122"/>
                 <a:cs typeface="Arial" pitchFamily="34" charset="-120"/>
               </a:rPr>
-              <a:t>learns a velocity field along simpler, straighter paths</a:t>
+              <a:t>feature caching and INT8/FP8 cut the cost per call, not NFE</a:t>
             </a:r>
             <a:endParaRPr lang="en-US" sz="1050" dirty="0"/>
           </a:p>
@@ -4991,7 +4991,7 @@
                 <a:ea typeface="Arial" pitchFamily="34" charset="-122"/>
                 <a:cs typeface="Arial" pitchFamily="34" charset="-120"/>
               </a:rPr>
-              <a:t>near-identical transformer backbone, different objective — a controlled pair</a:t>
+              <a:t>same architecture and GFLOPs, different objective — a controlled pair</a:t>
             </a:r>
             <a:endParaRPr lang="en-US" sz="1050" dirty="0"/>
           </a:p>
@@ -5092,7 +5092,7 @@
                 <a:ea typeface="Arial" pitchFamily="34" charset="-122"/>
                 <a:cs typeface="Arial" pitchFamily="34" charset="-120"/>
               </a:rPr>
-              <a:t>FLOPs and parameter counts disagree with measured efficiency</a:t>
+              <a:t>FORA: 0.99× on an RTX 5090 at batch 1 — FLOP cuts are not speedups</a:t>
             </a:r>
             <a:endParaRPr lang="en-US" sz="1050" dirty="0"/>
           </a:p>
@@ -5195,7 +5195,7 @@
                 <a:ea typeface="Georgia" pitchFamily="34" charset="-122"/>
                 <a:cs typeface="Georgia" pitchFamily="34" charset="-120"/>
               </a:rPr>
-              <a:t>Nobody checks whether diffusion-vs-flow conclusions transfer across hardware under one shared measurement protocol.</a:t>
+              <a:t>Nobody checks whether caching and quantization speedups — or diffusion-vs-flow conclusions — transfer to another GPU.</a:t>
             </a:r>
             <a:endParaRPr lang="en-US" sz="1600" dirty="0"/>
           </a:p>
@@ -5234,7 +5234,7 @@
                 <a:ea typeface="Arial" pitchFamily="34" charset="-122"/>
                 <a:cs typeface="Arial" pitchFamily="34" charset="-120"/>
               </a:rPr>
-              <a:t>Even FID shifts with evaluation details — so the protocol itself has to be fixed and published.</a:t>
+              <a:t>A recent survey names cross-platform behaviour as an open problem — so the protocol itself is fixed and published.</a:t>
             </a:r>
             <a:endParaRPr lang="en-US" sz="1050" dirty="0"/>
           </a:p>
@@ -6280,7 +6280,7 @@
                           <a:ea typeface="Arial" pitchFamily="34" charset="-122"/>
                           <a:cs typeface="Arial" pitchFamily="34" charset="-120"/>
                         </a:rPr>
-                        <a:t>Precision</a:t>
+                        <a:t>Acceleration</a:t>
                       </a:r>
                       <a:endParaRPr lang="en-US" sz="1100" dirty="0">
                         <a:latin typeface="Arial" charset="0"/>
@@ -6327,7 +6327,7 @@
                           <a:ea typeface="Arial" pitchFamily="34" charset="-122"/>
                           <a:cs typeface="Arial" pitchFamily="34" charset="-120"/>
                         </a:rPr>
-                        <a:t>bf16 · fp32</a:t>
+                        <a:t>fp16, cache, INT8, FP8</a:t>
                       </a:r>
                       <a:endParaRPr lang="en-US" sz="1100" dirty="0">
                         <a:latin typeface="Arial" charset="0"/>
@@ -6374,7 +6374,7 @@
                           <a:ea typeface="Arial" pitchFamily="34" charset="-122"/>
                           <a:cs typeface="Arial" pitchFamily="34" charset="-120"/>
                         </a:rPr>
-                        <a:t>bf16 · fp32</a:t>
+                        <a:t>fp16, cache, INT8, FP8</a:t>
                       </a:r>
                       <a:endParaRPr lang="en-US" sz="1100" dirty="0">
                         <a:latin typeface="Arial" charset="0"/>
@@ -6421,7 +6421,7 @@
                           <a:ea typeface="Courier New" pitchFamily="34" charset="-122"/>
                           <a:cs typeface="Courier New" pitchFamily="34" charset="-120"/>
                         </a:rPr>
-                        <a:t>2</a:t>
+                        <a:t>4</a:t>
                       </a:r>
                       <a:endParaRPr lang="en-US" sz="1100" dirty="0">
                         <a:latin typeface="Courier New" charset="0"/>
@@ -6517,7 +6517,7 @@
                           <a:ea typeface="Arial" pitchFamily="34" charset="-122"/>
                           <a:cs typeface="Arial" pitchFamily="34" charset="-120"/>
                         </a:rPr>
-                        <a:t>1 · 8  (timing only)</a:t>
+                        <a:t>1 · 16  (timing only)</a:t>
                       </a:r>
                       <a:endParaRPr lang="en-US" sz="1100" dirty="0">
                         <a:latin typeface="Arial" charset="0"/>
@@ -6564,7 +6564,7 @@
                           <a:ea typeface="Arial" pitchFamily="34" charset="-122"/>
                           <a:cs typeface="Arial" pitchFamily="34" charset="-120"/>
                         </a:rPr>
-                        <a:t>1 · 8  (timing only)</a:t>
+                        <a:t>1 · 16  (timing only)</a:t>
                       </a:r>
                       <a:endParaRPr lang="en-US" sz="1100" dirty="0">
                         <a:latin typeface="Arial" charset="0"/>
@@ -6679,7 +6679,7 @@
                 <a:ea typeface="Courier New" pitchFamily="34" charset="-122"/>
                 <a:cs typeface="Courier New" pitchFamily="34" charset="-120"/>
               </a:rPr>
-              <a:t>2 × 2 × 3 × 2</a:t>
+              <a:t>2 × 2 × 3 × 4</a:t>
             </a:r>
             <a:endParaRPr lang="en-US" sz="1300" dirty="0"/>
           </a:p>
@@ -6718,7 +6718,7 @@
                 <a:ea typeface="Georgia" pitchFamily="34" charset="-122"/>
                 <a:cs typeface="Georgia" pitchFamily="34" charset="-120"/>
               </a:rPr>
-              <a:t>24</a:t>
+              <a:t>48</a:t>
             </a:r>
             <a:endParaRPr lang="en-US" sz="8000" dirty="0"/>
           </a:p>
@@ -6757,7 +6757,7 @@
                 <a:ea typeface="Arial" pitchFamily="34" charset="-122"/>
                 <a:cs typeface="Arial" pitchFamily="34" charset="-120"/>
               </a:rPr>
-              <a:t>model–sampler–step–precision configurations</a:t>
+              <a:t>model–sampler–step–acceleration configurations</a:t>
             </a:r>
             <a:endParaRPr lang="en-US" sz="1100" dirty="0"/>
           </a:p>
@@ -6819,7 +6819,7 @@
                 <a:ea typeface="Arial" pitchFamily="34" charset="-122"/>
                 <a:cs typeface="Arial" pitchFamily="34" charset="-120"/>
               </a:rPr>
-              <a:t>Fixed throughout: guidance scale, compile settings, seeds, class labels. Every network call counts toward NFE.</a:t>
+              <a:t>Fixed: guidance scale, compile settings, seeds, class labels. NFE counts every call; FLOPs are counted separately, so cached calls show as cheaper.</a:t>
             </a:r>
             <a:endParaRPr lang="en-US" sz="950" dirty="0"/>
           </a:p>
@@ -7117,7 +7117,7 @@
                 <a:ea typeface="Courier New" pitchFamily="34" charset="-122"/>
                 <a:cs typeface="Courier New" pitchFamily="34" charset="-120"/>
               </a:rPr>
-              <a:t>LOCAL GPU</a:t>
+              <a:t>RTX 5080 · LOCAL</a:t>
             </a:r>
             <a:endParaRPr lang="en-US" sz="1000" dirty="0"/>
           </a:p>
@@ -7156,7 +7156,7 @@
                 <a:ea typeface="Georgia" pitchFamily="34" charset="-122"/>
                 <a:cs typeface="Georgia" pitchFamily="34" charset="-120"/>
               </a:rPr>
-              <a:t>Workhorse</a:t>
+              <a:t>Blackwell · every precision</a:t>
             </a:r>
             <a:endParaRPr lang="en-US" sz="1300" dirty="0"/>
           </a:p>
@@ -7195,7 +7195,7 @@
                 <a:ea typeface="Arial" pitchFamily="34" charset="-122"/>
                 <a:cs typeface="Arial" pitchFamily="34" charset="-120"/>
               </a:rPr>
-              <a:t>Quality generation, pilot sweeps</a:t>
+              <a:t>All image generation, pilot sweeps</a:t>
             </a:r>
             <a:endParaRPr lang="en-US" sz="1050" dirty="0"/>
           </a:p>
@@ -7298,7 +7298,7 @@
                 <a:ea typeface="Georgia" pitchFamily="34" charset="-122"/>
                 <a:cs typeface="Georgia" pitchFamily="34" charset="-120"/>
               </a:rPr>
-              <a:t>Turing · no native bf16</a:t>
+              <a:t>Turing · no bf16, no FP8</a:t>
             </a:r>
             <a:endParaRPr lang="en-US" sz="1300" dirty="0"/>
           </a:p>
@@ -7440,7 +7440,7 @@
                 <a:ea typeface="Georgia" pitchFamily="34" charset="-122"/>
                 <a:cs typeface="Georgia" pitchFamily="34" charset="-120"/>
               </a:rPr>
-              <a:t>Hopper-class · scarce hours</a:t>
+              <a:t>Hopper · FP8 · scarce hours</a:t>
             </a:r>
             <a:endParaRPr lang="en-US" sz="1300" dirty="0"/>
           </a:p>
@@ -7541,7 +7541,7 @@
                 <a:ea typeface="Courier New" pitchFamily="34" charset="-122"/>
                 <a:cs typeface="Courier New" pitchFamily="34" charset="-120"/>
               </a:rPr>
-              <a:t>MEASUREMENT PROTOCOL — IDENTICAL ON EVERY DEVICE, ONE GPU PER RUN</a:t>
+              <a:t>MEASUREMENT PROTOCOL — SAME ON EVERY DEVICE, ONE GPU PER RUN</a:t>
             </a:r>
             <a:endParaRPr lang="en-US" sz="850" dirty="0"/>
           </a:p>
@@ -7681,7 +7681,7 @@
                 <a:ea typeface="Arial" pitchFamily="34" charset="-122"/>
                 <a:cs typeface="Arial" pitchFamily="34" charset="-120"/>
               </a:rPr>
-              <a:t>versions, seeds, class labels</a:t>
+              <a:t>one implementation, same versions, logged</a:t>
             </a:r>
             <a:endParaRPr lang="en-US" sz="950" dirty="0"/>
           </a:p>
@@ -8101,7 +8101,7 @@
                 <a:ea typeface="Arial" pitchFamily="34" charset="-122"/>
                 <a:cs typeface="Arial" pitchFamily="34" charset="-120"/>
               </a:rPr>
-              <a:t>peak memory, energy (NVML)</a:t>
+              <a:t>peak memory, energy (NVML, GPU only)</a:t>
             </a:r>
             <a:endParaRPr lang="en-US" sz="950" dirty="0"/>
           </a:p>
@@ -8578,7 +8578,7 @@
                 <a:ea typeface="Arial" pitchFamily="34" charset="-122"/>
                 <a:cs typeface="Arial" pitchFamily="34" charset="-120"/>
               </a:rPr>
-              <a:t>All 24 configurations × 2,000 images · clean-fid, fixed ImageNet reference statistics</a:t>
+              <a:t>All 48 configurations × 2,000 images on the RTX 5080 · clean-fid, fixed ImageNet statistics</a:t>
             </a:r>
             <a:endParaRPr lang="en-US" sz="1050" dirty="0"/>
           </a:p>
@@ -8860,7 +8860,7 @@
                 <a:ea typeface="Arial" pitchFamily="34" charset="-122"/>
                 <a:cs typeface="Arial" pitchFamily="34" charset="-120"/>
               </a:rPr>
-              <a:t>same weights and seeds give the same images up to numerical noise — and selected outputs are re-generated on every device to verify exactly that.</a:t>
+              <a:t>quality belongs to the configuration, not the device. The RTX 5080 runs every configuration, and a subset is re-generated on the T4 and GH200 to verify that.</a:t>
             </a:r>
             <a:endParaRPr lang="en-US" sz="1050" dirty="0"/>
           </a:p>
@@ -9768,7 +9768,7 @@
                 <a:ea typeface="Arial" pitchFamily="34" charset="-122"/>
                 <a:cs typeface="Arial" pitchFamily="34" charset="-120"/>
               </a:rPr>
-              <a:t>Regress latency &amp; energy on NFE per device; read the sampler-specific residuals.</a:t>
+              <a:t>Control: regress latency &amp; energy on NFE and FLOPs per device and batch size.</a:t>
             </a:r>
             <a:endParaRPr lang="en-US" sz="1050" dirty="0"/>
           </a:p>
@@ -9869,7 +9869,7 @@
                 <a:ea typeface="Arial" pitchFamily="34" charset="-122"/>
                 <a:cs typeface="Arial" pitchFamily="34" charset="-120"/>
               </a:rPr>
-              <a:t>FID–latency and FID–energy Pareto frontiers per device; flag configs that change status.</a:t>
+              <a:t>Per-device frontiers; flag configs efficient on one GPU but dominated on another.</a:t>
             </a:r>
             <a:endParaRPr lang="en-US" sz="1050" dirty="0"/>
           </a:p>
@@ -9970,7 +9970,7 @@
                 <a:ea typeface="Arial" pitchFamily="34" charset="-122"/>
                 <a:cs typeface="Arial" pitchFamily="34" charset="-120"/>
               </a:rPr>
-              <a:t>Kendall's τ between device rankings.</a:t>
+              <a:t>Kendall's τ between devices, plain vs accelerated, with bootstrap intervals.</a:t>
             </a:r>
             <a:endParaRPr lang="en-US" sz="1050" dirty="0"/>
           </a:p>
@@ -10071,7 +10071,7 @@
                 <a:ea typeface="Arial" pitchFamily="34" charset="-122"/>
                 <a:cs typeface="Arial" pitchFamily="34" charset="-120"/>
               </a:rPr>
-              <a:t>FID increase at matched measured cost — not matched NFE.</a:t>
+              <a:t>FID cost of caching by family and step count, vs consecutive-step similarity.</a:t>
             </a:r>
             <a:endParaRPr lang="en-US" sz="1050" dirty="0"/>
           </a:p>
@@ -10500,7 +10500,7 @@
                 <a:ea typeface="Arial" pitchFamily="34" charset="-122"/>
                 <a:cs typeface="Arial" pitchFamily="34" charset="-120"/>
               </a:rPr>
-              <a:t>One large job: 24 configs × 2,000 pilot images</a:t>
+              <a:t>Pilot: 48 configs × 2,000 images ≈ 6 GPU-hours</a:t>
             </a:r>
             <a:endParaRPr lang="en-US" sz="1150" dirty="0"/>
           </a:p>
@@ -10734,7 +10734,7 @@
                 <a:ea typeface="Arial" pitchFamily="34" charset="-122"/>
                 <a:cs typeface="Arial" pitchFamily="34" charset="-120"/>
               </a:rPr>
-              <a:t>Free or already-available hardware only</a:t>
+              <a:t>Week-1 kernel smoke test fixes what runs where</a:t>
             </a:r>
             <a:endParaRPr lang="en-US" sz="1150" dirty="0"/>
           </a:p>
@@ -10874,7 +10874,7 @@
                 <a:ea typeface="Arial" pitchFamily="34" charset="-122"/>
                 <a:cs typeface="Arial" pitchFamily="34" charset="-120"/>
               </a:rPr>
-              <a:t>Drop fp32 quality generation</a:t>
+              <a:t>Drop FP8</a:t>
             </a:r>
             <a:endParaRPr lang="en-US" sz="1150" dirty="0"/>
           </a:p>
@@ -11030,7 +11030,7 @@
                 <a:ea typeface="Arial" pitchFamily="34" charset="-122"/>
                 <a:cs typeface="Arial" pitchFamily="34" charset="-120"/>
               </a:rPr>
-              <a:t>Checkpoint mismatch → small parameter-efficient pilot, never full training</a:t>
+              <a:t>Drop the 32-step level for accelerated configurations</a:t>
             </a:r>
             <a:endParaRPr lang="en-US" sz="1150" dirty="0"/>
           </a:p>
@@ -11083,7 +11083,7 @@
                 <a:ea typeface="Arial" pitchFamily="34" charset="-122"/>
                 <a:cs typeface="Arial" pitchFamily="34" charset="-120"/>
               </a:rPr>
-              <a:t>both model families, all three step counts, cross-device timing.</a:t>
+              <a:t>both model families, caching, cross-device timing.</a:t>
             </a:r>
             <a:endParaRPr lang="en-US" sz="1050" dirty="0"/>
           </a:p>
@@ -12224,7 +12224,7 @@
                 <a:ea typeface="Arial" pitchFamily="34" charset="-122"/>
                 <a:cs typeface="Arial" pitchFamily="34" charset="-120"/>
               </a:rPr>
-              <a:t>checkpoints, env, protocol</a:t>
+              <a:t>pinned env, kernel smoke test</a:t>
             </a:r>
             <a:endParaRPr lang="en-US" sz="850" dirty="0"/>
           </a:p>
@@ -12327,7 +12327,7 @@
                 <a:ea typeface="Arial" pitchFamily="34" charset="-122"/>
                 <a:cs typeface="Arial" pitchFamily="34" charset="-120"/>
               </a:rPr>
-              <a:t>timing, memory, energy</a:t>
+              <a:t>timing, energy, cache, INT8/FP8</a:t>
             </a:r>
             <a:endParaRPr lang="en-US" sz="850" dirty="0"/>
           </a:p>
@@ -12739,7 +12739,7 @@
                 <a:ea typeface="Arial" pitchFamily="34" charset="-122"/>
                 <a:cs typeface="Arial" pitchFamily="34" charset="-120"/>
               </a:rPr>
-              <a:t>NFE, Pareto, τ, report</a:t>
+              <a:t>NFE/FLOPs, Pareto, τ, report</a:t>
             </a:r>
             <a:endParaRPr lang="en-US" sz="850" dirty="0"/>
           </a:p>

</xml_diff>

<commit_message>
Adopt revised proposal: transfer penalty as primary outcome
Rebuilds the revised proposal in LaTeX with a concrete feasibility
section and cut order, the FORA/AccelAes motivation, ML.ENERGY, and a
course line. Aligns the 3-slide deck and README with the new research
question and H1-H3, and adds the ReportLab revision for reference.

Co-Authored-By: Claude Opus 5.5 <noreply@anthropic.com>
</commit_message>
<xml_diff>
--- a/docs/Hardware_Efficient_GenModels_Proposal.pptx
+++ b/docs/Hardware_Efficient_GenModels_Proposal.pptx
@@ -504,7 +504,7 @@
           <a:p>
             <a:r>
               <a:rPr lang="en-US" dirty="0"/>
-              <a:t>One-line pitch: papers report '2× faster', but that number is measured on one GPU, and caching or 8-bit kernels change the cost of a call without changing the step count. I test whether those conclusions, and diffusion-vs-flow ones, survive a change of GPU. The figure is a cartoon of why flow matching might need fewer steps: straighter paths.</a:t>
+              <a:t>One-line pitch: if you pick the fastest sampling setup on your GPU at a given image quality, is it still the right choice on mine? Caching and 8-bit kernels change the cost of a network call without changing the step count, and their speedups are measured on one GPU. The figure is a cartoon of diffusion and flow-matching sampling paths.</a:t>
             </a:r>
             <a:endParaRPr lang="en-US" dirty="0"/>
           </a:p>
@@ -592,7 +592,7 @@
           <a:p>
             <a:r>
               <a:rPr lang="en-US" dirty="0"/>
-              <a:t>Motivation: feature caching and INT8/FP8 kernels cut the cost of a call, not the number of calls, and their speedups are reported on one GPU. FORA, for example, gave 0.99× (no speedup) on an RTX 5090 at batch 1. H1 is a control: DiT and SiT have the same architecture and GFLOPs, so without acceleration NFE should predict latency on every GPU. H2 and H3 are the real tests. All three are falsifiable; stable rankings would also be a useful result.</a:t>
+              <a:t>Motivation: speedups are reported on one GPU and are fragile; FORA gave 0.99× (no speedup) on an RTX 5090 at batch 1. H1 is the baseline: if each GPU only scales latency by a constant, the best choice transfers. H2 explains departures with a small cost model (compute, memory, fixed overhead) checked on held-out configurations. H3 is exploratory: does feature-reuse error predict how much caching hurts FID? I deliberately make no claim that flow matching tolerates caching better.</a:t>
             </a:r>
             <a:endParaRPr lang="en-US" dirty="0"/>
           </a:p>
@@ -680,7 +680,7 @@
           <a:p>
             <a:r>
               <a:rPr lang="en-US" dirty="0"/>
-              <a:t>48 = 2 models × 2 samplers each × 3 step counts × 4 accelerations (none, feature caching, INT8, FP8), all public checkpoints, nothing trained. The three GPUs differ in precision support: the T4 has no bf16 or FP8, so anything it cannot run is recorded as unavailable. All images are generated once on the RTX 5080 (about 6 GPU-hours for a 2,000-image pilot); the other two GPUs only run short timing sweeps. Either outcome is informative: stable rankings validate NFE and FLOPs; unstable ones mean speedup claims need their hardware attached.</a:t>
+              <a:t>48 = 2 models × 2 samplers each × 3 step counts × 4 execution modes (FP16, FORA-style caching, INT8, FP8), all public checkpoints, nothing trained. Kernels a GPU lacks, such as FP8 on the T4, are reported separately and excluded from transfer comparisons. Transfer penalty: for each pair of GPUs and an FID ceiling, take the fastest eligible configuration on the source, measure it on the target, divide by the target's own fastest eligible latency, minus one. Images are generated on the RTX 5080 (about 6 GPU-hours for the pilot), with a subset regenerated on the other GPUs to confirm quality transfers. Stable choices with small penalties are also a useful result.</a:t>
             </a:r>
             <a:endParaRPr lang="en-US" dirty="0"/>
           </a:p>
@@ -1125,7 +1125,7 @@
                 <a:ea typeface="Georgia" pitchFamily="34" charset="-122"/>
                 <a:cs typeface="Georgia" pitchFamily="34" charset="-120"/>
               </a:rPr>
-              <a:t>Does hardware change which generative model is efficient?</a:t>
+              <a:t>Do efficient generative sampling choices transfer across GPUs?</a:t>
             </a:r>
             <a:endParaRPr lang="en-US" sz="3000" dirty="0"/>
           </a:p>
@@ -1164,7 +1164,7 @@
                 <a:ea typeface="Georgia" pitchFamily="34" charset="-122"/>
                 <a:cs typeface="Georgia" pitchFamily="34" charset="-120"/>
               </a:rPr>
-              <a:t>Diffusion and flow-matching samplers with caching and INT8/FP8, measured across three GPU generations.</a:t>
+              <a:t>Training-free acceleration of diffusion and flow-matching transformers, measured on three GPU platforms.</a:t>
             </a:r>
             <a:endParaRPr lang="en-US" sz="1400" dirty="0"/>
           </a:p>
@@ -2920,7 +2920,7 @@
                 <a:ea typeface="Georgia" pitchFamily="34" charset="-122"/>
                 <a:cs typeface="Georgia" pitchFamily="34" charset="-120"/>
               </a:rPr>
-              <a:t>“When an acceleration changes the cost of a network call but not the number of calls, do quality–cost rankings survive a change of GPU?”</a:t>
+              <a:t>“Do quality–efficiency conclusions about diffusion and flow-matching sampling remain valid across GPUs when training-free accelerations are introduced?”</a:t>
             </a:r>
             <a:endParaRPr lang="en-US" sz="1700" dirty="0"/>
           </a:p>
@@ -2998,7 +2998,7 @@
                 <a:ea typeface="Georgia" pitchFamily="34" charset="-122"/>
                 <a:cs typeface="Georgia" pitchFamily="34" charset="-120"/>
               </a:rPr>
-              <a:t>Control</a:t>
+              <a:t>Transfer baseline</a:t>
             </a:r>
             <a:endParaRPr lang="en-US" sz="1400" dirty="0"/>
           </a:p>
@@ -3037,7 +3037,7 @@
                 <a:ea typeface="Arial" pitchFamily="34" charset="-122"/>
                 <a:cs typeface="Arial" pitchFamily="34" charset="-120"/>
               </a:rPr>
-              <a:t>Without acceleration, latency is linear in NFE on every device. DiT and SiT cost the same per call, so this validates the harness.</a:t>
+              <a:t>Plain sampling differs across GPUs only by one latency factor per device, so the best choice transfers.</a:t>
             </a:r>
             <a:endParaRPr lang="en-US" sz="1100" dirty="0"/>
           </a:p>
@@ -3138,7 +3138,7 @@
                 <a:ea typeface="Georgia" pitchFamily="34" charset="-122"/>
                 <a:cs typeface="Georgia" pitchFamily="34" charset="-120"/>
               </a:rPr>
-              <a:t>Rankings move</a:t>
+              <a:t>Cost explanation</a:t>
             </a:r>
             <a:endParaRPr lang="en-US" sz="1400" dirty="0"/>
           </a:p>
@@ -3177,7 +3177,7 @@
                 <a:ea typeface="Arial" pitchFamily="34" charset="-122"/>
                 <a:cs typeface="Arial" pitchFamily="34" charset="-120"/>
               </a:rPr>
-              <a:t>Caching and INT8/FP8 speedups depend on GPU and batch size, so they reorder the frontier in ways NFE and FLOPs cannot predict.</a:t>
+              <a:t>Caching and INT8/FP8 add device-specific effects that NFE and FLOPs miss; a compute–memory–overhead model predicts them.</a:t>
             </a:r>
             <a:endParaRPr lang="en-US" sz="1100" dirty="0"/>
           </a:p>
@@ -3278,7 +3278,7 @@
                 <a:ea typeface="Georgia" pitchFamily="34" charset="-122"/>
                 <a:cs typeface="Georgia" pitchFamily="34" charset="-120"/>
               </a:rPr>
-              <a:t>Who tolerates caching</a:t>
+              <a:t>Quality mechanism</a:t>
             </a:r>
             <a:endParaRPr lang="en-US" sz="1400" dirty="0"/>
           </a:p>
@@ -3317,7 +3317,7 @@
                 <a:ea typeface="Arial" pitchFamily="34" charset="-122"/>
                 <a:cs typeface="Arial" pitchFamily="34" charset="-120"/>
               </a:rPr>
-              <a:t>Flow matching should lose less quality under caching than diffusion. At 8 steps caching is predicted to fail outright.</a:t>
+              <a:t>Exploratory: feature-reuse error predicts how much caching hurts quality better than step count. No assumption that flow matching wins.</a:t>
             </a:r>
             <a:endParaRPr lang="en-US" sz="1100" dirty="0"/>
           </a:p>
@@ -3427,7 +3427,7 @@
                 <a:ea typeface="Georgia" pitchFamily="34" charset="-122"/>
                 <a:cs typeface="Georgia" pitchFamily="34" charset="-120"/>
               </a:rPr>
-              <a:t>A complete factorial on three GPUs — no training</a:t>
+              <a:t>48 configurations on RTX 5080, T4 and GH200</a:t>
             </a:r>
             <a:endParaRPr lang="en-US" sz="2500" dirty="0"/>
           </a:p>
@@ -4902,7 +4902,7 @@
                 <a:ea typeface="Arial" pitchFamily="34" charset="-122"/>
                 <a:cs typeface="Arial" pitchFamily="34" charset="-120"/>
               </a:rPr>
-              <a:t>Timed on RTX 5080 (Blackwell), Colab T4 (Turing) and GH200 (Hopper). Output: Pareto frontiers for each GPU and Kendall's τ between them.</a:t>
+              <a:t>Primary outcome, transfer penalty: tune on one GPU at a fixed FID; how much slower is that choice on another GPU than its own best? At most 5% is near-optimal.</a:t>
             </a:r>
             <a:endParaRPr lang="en-US" sz="950" dirty="0"/>
           </a:p>

</xml_diff>